<commit_message>
Presentation Spotify : titre 'Objectifs et valeur metier' et numerotation des diapositives
</commit_message>
<xml_diff>
--- a/1_Spotify_Data_Governance/versions_docx_ppt/4_Presentation_Gouvernance_Spotify.pptx
+++ b/1_Spotify_Data_Governance/versions_docx_ppt/4_Presentation_Gouvernance_Spotify.pptx
@@ -1538,6 +1538,41 @@
           <a:chExt cx="0" cy="0"/>
         </a:xfrm>
       </p:grpSpPr>
+      <p:sp>
+        <p:nvSpPr>
+          <p:cNvPr id="2" name="TextBox 1"/>
+          <p:cNvSpPr txBox="1"/>
+          <p:nvPr/>
+        </p:nvSpPr>
+        <p:spPr>
+          <a:xfrm>
+            <a:off x="11064240" y="6400800"/>
+            <a:ext cx="1005840" cy="365760"/>
+          </a:xfrm>
+          <a:prstGeom prst="rect">
+            <a:avLst/>
+          </a:prstGeom>
+          <a:noFill/>
+        </p:spPr>
+        <p:txBody>
+          <a:bodyPr wrap="none">
+            <a:spAutoFit/>
+          </a:bodyPr>
+          <a:lstStyle/>
+          <a:p>
+            <a:pPr algn="r"/>
+            <a:r>
+              <a:rPr sz="1100">
+                <a:solidFill>
+                  <a:srgbClr val="C9D3E0"/>
+                </a:solidFill>
+                <a:latin typeface="Calibri"/>
+              </a:rPr>
+              <a:t>1 / 8</a:t>
+            </a:r>
+          </a:p>
+        </p:txBody>
+      </p:sp>
     </p:spTree>
   </p:cSld>
   <p:clrMapOvr>
@@ -1662,6 +1697,10 @@
           </a:solidFill>
           <a:ln/>
         </p:spPr>
+        <p:txBody>
+          <a:bodyPr/>
+          <a:p/>
+        </p:txBody>
       </p:sp>
       <p:sp>
         <p:nvSpPr>
@@ -1762,6 +1801,10 @@
           </a:solidFill>
           <a:ln/>
         </p:spPr>
+        <p:txBody>
+          <a:bodyPr/>
+          <a:p/>
+        </p:txBody>
       </p:sp>
       <p:sp>
         <p:nvSpPr>
@@ -1862,6 +1905,10 @@
           </a:solidFill>
           <a:ln/>
         </p:spPr>
+        <p:txBody>
+          <a:bodyPr/>
+          <a:p/>
+        </p:txBody>
       </p:sp>
       <p:sp>
         <p:nvSpPr>
@@ -1962,6 +2009,10 @@
           </a:solidFill>
           <a:ln/>
         </p:spPr>
+        <p:txBody>
+          <a:bodyPr/>
+          <a:p/>
+        </p:txBody>
       </p:sp>
       <p:sp>
         <p:nvSpPr>
@@ -2077,6 +2128,41 @@
               <a:t>Une forte maturité technique (architecture et analytique à 4 sur 5) mais une maturité organisationnelle plus faible sur la gouvernance, la conformité, l'accessibilité et l'intégration des données.</a:t>
             </a:r>
             <a:endParaRPr lang="en-US" sz="1400" dirty="0"/>
+          </a:p>
+        </p:txBody>
+      </p:sp>
+      <p:sp>
+        <p:nvSpPr>
+          <p:cNvPr id="17" name="TextBox 16"/>
+          <p:cNvSpPr txBox="1"/>
+          <p:nvPr/>
+        </p:nvSpPr>
+        <p:spPr>
+          <a:xfrm>
+            <a:off x="11064240" y="6400800"/>
+            <a:ext cx="1005840" cy="365760"/>
+          </a:xfrm>
+          <a:prstGeom prst="rect">
+            <a:avLst/>
+          </a:prstGeom>
+          <a:noFill/>
+        </p:spPr>
+        <p:txBody>
+          <a:bodyPr wrap="none">
+            <a:spAutoFit/>
+          </a:bodyPr>
+          <a:lstStyle/>
+          <a:p>
+            <a:pPr algn="r"/>
+            <a:r>
+              <a:rPr sz="1100">
+                <a:solidFill>
+                  <a:srgbClr val="1F3864"/>
+                </a:solidFill>
+                <a:latin typeface="Calibri"/>
+              </a:rPr>
+              <a:t>2 / 8</a:t>
+            </a:r>
           </a:p>
         </p:txBody>
       </p:sp>
@@ -2177,7 +2263,7 @@
                 <a:ea typeface="Calibri" pitchFamily="34" charset="-122"/>
                 <a:cs typeface="Calibri" pitchFamily="34" charset="-120"/>
               </a:rPr>
-              <a:t>Nos objectifs et leur valeur métier</a:t>
+              <a:t>Objectifs et valeur métier</a:t>
             </a:r>
             <a:endParaRPr lang="en-US" sz="2800" dirty="0"/>
           </a:p>
@@ -2204,6 +2290,10 @@
           </a:solidFill>
           <a:ln/>
         </p:spPr>
+        <p:txBody>
+          <a:bodyPr/>
+          <a:p/>
+        </p:txBody>
       </p:sp>
       <p:sp>
         <p:nvSpPr>
@@ -2371,6 +2461,10 @@
           </a:solidFill>
           <a:ln/>
         </p:spPr>
+        <p:txBody>
+          <a:bodyPr/>
+          <a:p/>
+        </p:txBody>
       </p:sp>
       <p:sp>
         <p:nvSpPr>
@@ -2514,6 +2608,41 @@
               <a:t>Une organisation prête à passer à l'échelle</a:t>
             </a:r>
             <a:endParaRPr lang="en-US" sz="1500" dirty="0"/>
+          </a:p>
+        </p:txBody>
+      </p:sp>
+      <p:sp>
+        <p:nvSpPr>
+          <p:cNvPr id="10" name="TextBox 9"/>
+          <p:cNvSpPr txBox="1"/>
+          <p:nvPr/>
+        </p:nvSpPr>
+        <p:spPr>
+          <a:xfrm>
+            <a:off x="11064240" y="6400800"/>
+            <a:ext cx="1005840" cy="365760"/>
+          </a:xfrm>
+          <a:prstGeom prst="rect">
+            <a:avLst/>
+          </a:prstGeom>
+          <a:noFill/>
+        </p:spPr>
+        <p:txBody>
+          <a:bodyPr wrap="none">
+            <a:spAutoFit/>
+          </a:bodyPr>
+          <a:lstStyle/>
+          <a:p>
+            <a:pPr algn="r"/>
+            <a:r>
+              <a:rPr sz="1100">
+                <a:solidFill>
+                  <a:srgbClr val="1F3864"/>
+                </a:solidFill>
+                <a:latin typeface="Calibri"/>
+              </a:rPr>
+              <a:t>3 / 8</a:t>
+            </a:r>
           </a:p>
         </p:txBody>
       </p:sp>
@@ -2641,6 +2770,10 @@
           </a:solidFill>
           <a:ln/>
         </p:spPr>
+        <p:txBody>
+          <a:bodyPr/>
+          <a:p/>
+        </p:txBody>
       </p:sp>
       <p:sp>
         <p:nvSpPr>
@@ -2702,6 +2835,10 @@
           </a:solidFill>
           <a:ln/>
         </p:spPr>
+        <p:txBody>
+          <a:bodyPr/>
+          <a:p/>
+        </p:txBody>
       </p:sp>
       <p:sp>
         <p:nvSpPr>
@@ -2763,6 +2900,10 @@
           </a:solidFill>
           <a:ln/>
         </p:spPr>
+        <p:txBody>
+          <a:bodyPr/>
+          <a:p/>
+        </p:txBody>
       </p:sp>
       <p:sp>
         <p:nvSpPr>
@@ -2824,6 +2965,10 @@
           </a:solidFill>
           <a:ln/>
         </p:spPr>
+        <p:txBody>
+          <a:bodyPr/>
+          <a:p/>
+        </p:txBody>
       </p:sp>
       <p:sp>
         <p:nvSpPr>
@@ -2885,6 +3030,10 @@
           </a:solidFill>
           <a:ln/>
         </p:spPr>
+        <p:txBody>
+          <a:bodyPr/>
+          <a:p/>
+        </p:txBody>
       </p:sp>
       <p:sp>
         <p:nvSpPr>
@@ -2946,6 +3095,10 @@
           </a:solidFill>
           <a:ln/>
         </p:spPr>
+        <p:txBody>
+          <a:bodyPr/>
+          <a:p/>
+        </p:txBody>
       </p:sp>
       <p:sp>
         <p:nvSpPr>
@@ -3007,6 +3160,10 @@
           </a:solidFill>
           <a:ln/>
         </p:spPr>
+        <p:txBody>
+          <a:bodyPr/>
+          <a:p/>
+        </p:txBody>
       </p:sp>
       <p:sp>
         <p:nvSpPr>
@@ -3068,6 +3225,10 @@
           </a:solidFill>
           <a:ln/>
         </p:spPr>
+        <p:txBody>
+          <a:bodyPr/>
+          <a:p/>
+        </p:txBody>
       </p:sp>
       <p:sp>
         <p:nvSpPr>
@@ -3129,6 +3290,10 @@
           </a:solidFill>
           <a:ln/>
         </p:spPr>
+        <p:txBody>
+          <a:bodyPr/>
+          <a:p/>
+        </p:txBody>
       </p:sp>
       <p:sp>
         <p:nvSpPr>
@@ -3166,6 +3331,41 @@
               <a:t>Usage éthique</a:t>
             </a:r>
             <a:endParaRPr lang="en-US" sz="1600" dirty="0"/>
+          </a:p>
+        </p:txBody>
+      </p:sp>
+      <p:sp>
+        <p:nvSpPr>
+          <p:cNvPr id="22" name="TextBox 21"/>
+          <p:cNvSpPr txBox="1"/>
+          <p:nvPr/>
+        </p:nvSpPr>
+        <p:spPr>
+          <a:xfrm>
+            <a:off x="11064240" y="6400800"/>
+            <a:ext cx="1005840" cy="365760"/>
+          </a:xfrm>
+          <a:prstGeom prst="rect">
+            <a:avLst/>
+          </a:prstGeom>
+          <a:noFill/>
+        </p:spPr>
+        <p:txBody>
+          <a:bodyPr wrap="none">
+            <a:spAutoFit/>
+          </a:bodyPr>
+          <a:lstStyle/>
+          <a:p>
+            <a:pPr algn="r"/>
+            <a:r>
+              <a:rPr sz="1100">
+                <a:solidFill>
+                  <a:srgbClr val="1F3864"/>
+                </a:solidFill>
+                <a:latin typeface="Calibri"/>
+              </a:rPr>
+              <a:t>4 / 8</a:t>
+            </a:r>
           </a:p>
         </p:txBody>
       </p:sp>
@@ -3579,6 +3779,41 @@
           </a:p>
         </p:txBody>
       </p:sp>
+      <p:sp>
+        <p:nvSpPr>
+          <p:cNvPr id="7" name="TextBox 6"/>
+          <p:cNvSpPr txBox="1"/>
+          <p:nvPr/>
+        </p:nvSpPr>
+        <p:spPr>
+          <a:xfrm>
+            <a:off x="11064240" y="6400800"/>
+            <a:ext cx="1005840" cy="365760"/>
+          </a:xfrm>
+          <a:prstGeom prst="rect">
+            <a:avLst/>
+          </a:prstGeom>
+          <a:noFill/>
+        </p:spPr>
+        <p:txBody>
+          <a:bodyPr wrap="none">
+            <a:spAutoFit/>
+          </a:bodyPr>
+          <a:lstStyle/>
+          <a:p>
+            <a:pPr algn="r"/>
+            <a:r>
+              <a:rPr sz="1100">
+                <a:solidFill>
+                  <a:srgbClr val="1F3864"/>
+                </a:solidFill>
+                <a:latin typeface="Calibri"/>
+              </a:rPr>
+              <a:t>5 / 8</a:t>
+            </a:r>
+          </a:p>
+        </p:txBody>
+      </p:sp>
     </p:spTree>
   </p:cSld>
   <p:clrMapOvr>
@@ -3727,6 +3962,10 @@
           </a:solidFill>
           <a:ln/>
         </p:spPr>
+        <p:txBody>
+          <a:bodyPr/>
+          <a:p/>
+        </p:txBody>
       </p:sp>
       <p:sp>
         <p:nvSpPr>
@@ -3894,6 +4133,10 @@
           </a:solidFill>
           <a:ln/>
         </p:spPr>
+        <p:txBody>
+          <a:bodyPr/>
+          <a:p/>
+        </p:txBody>
       </p:sp>
       <p:sp>
         <p:nvSpPr>
@@ -3970,6 +4213,41 @@
               <a:t>Le cœur algorithmique — moteur de recommandation et surveillance des biais — est développé en interne, car c'est ce qui différencie Spotify.</a:t>
             </a:r>
             <a:endParaRPr lang="en-US" sz="1350" dirty="0"/>
+          </a:p>
+        </p:txBody>
+      </p:sp>
+      <p:sp>
+        <p:nvSpPr>
+          <p:cNvPr id="11" name="TextBox 10"/>
+          <p:cNvSpPr txBox="1"/>
+          <p:nvPr/>
+        </p:nvSpPr>
+        <p:spPr>
+          <a:xfrm>
+            <a:off x="11064240" y="6400800"/>
+            <a:ext cx="1005840" cy="365760"/>
+          </a:xfrm>
+          <a:prstGeom prst="rect">
+            <a:avLst/>
+          </a:prstGeom>
+          <a:noFill/>
+        </p:spPr>
+        <p:txBody>
+          <a:bodyPr wrap="none">
+            <a:spAutoFit/>
+          </a:bodyPr>
+          <a:lstStyle/>
+          <a:p>
+            <a:pPr algn="r"/>
+            <a:r>
+              <a:rPr sz="1100">
+                <a:solidFill>
+                  <a:srgbClr val="1F3864"/>
+                </a:solidFill>
+                <a:latin typeface="Calibri"/>
+              </a:rPr>
+              <a:t>6 / 8</a:t>
+            </a:r>
           </a:p>
         </p:txBody>
       </p:sp>
@@ -4097,6 +4375,10 @@
           </a:solidFill>
           <a:ln/>
         </p:spPr>
+        <p:txBody>
+          <a:bodyPr/>
+          <a:p/>
+        </p:txBody>
       </p:sp>
       <p:sp>
         <p:nvSpPr>
@@ -4264,6 +4546,10 @@
           </a:solidFill>
           <a:ln/>
         </p:spPr>
+        <p:txBody>
+          <a:bodyPr/>
+          <a:p/>
+        </p:txBody>
       </p:sp>
       <p:sp>
         <p:nvSpPr>
@@ -4428,6 +4714,41 @@
               <a:t>Délai de correction des anomalies</a:t>
             </a:r>
             <a:endParaRPr lang="en-US" sz="1350" dirty="0"/>
+          </a:p>
+        </p:txBody>
+      </p:sp>
+      <p:sp>
+        <p:nvSpPr>
+          <p:cNvPr id="10" name="TextBox 9"/>
+          <p:cNvSpPr txBox="1"/>
+          <p:nvPr/>
+        </p:nvSpPr>
+        <p:spPr>
+          <a:xfrm>
+            <a:off x="11064240" y="6400800"/>
+            <a:ext cx="1005840" cy="365760"/>
+          </a:xfrm>
+          <a:prstGeom prst="rect">
+            <a:avLst/>
+          </a:prstGeom>
+          <a:noFill/>
+        </p:spPr>
+        <p:txBody>
+          <a:bodyPr wrap="none">
+            <a:spAutoFit/>
+          </a:bodyPr>
+          <a:lstStyle/>
+          <a:p>
+            <a:pPr algn="r"/>
+            <a:r>
+              <a:rPr sz="1100">
+                <a:solidFill>
+                  <a:srgbClr val="1F3864"/>
+                </a:solidFill>
+                <a:latin typeface="Calibri"/>
+              </a:rPr>
+              <a:t>7 / 8</a:t>
+            </a:r>
           </a:p>
         </p:txBody>
       </p:sp>
@@ -4555,6 +4876,10 @@
           </a:solidFill>
           <a:ln/>
         </p:spPr>
+        <p:txBody>
+          <a:bodyPr/>
+          <a:p/>
+        </p:txBody>
       </p:sp>
       <p:sp>
         <p:nvSpPr>
@@ -4722,6 +5047,10 @@
           </a:solidFill>
           <a:ln/>
         </p:spPr>
+        <p:txBody>
+          <a:bodyPr/>
+          <a:p/>
+        </p:txBody>
       </p:sp>
       <p:sp>
         <p:nvSpPr>
@@ -4844,6 +5173,41 @@
               <a:t>Mesurer, puis étendre au reste de l'organisation</a:t>
             </a:r>
             <a:endParaRPr lang="en-US" sz="1450" dirty="0"/>
+          </a:p>
+        </p:txBody>
+      </p:sp>
+      <p:sp>
+        <p:nvSpPr>
+          <p:cNvPr id="10" name="TextBox 9"/>
+          <p:cNvSpPr txBox="1"/>
+          <p:nvPr/>
+        </p:nvSpPr>
+        <p:spPr>
+          <a:xfrm>
+            <a:off x="11064240" y="6400800"/>
+            <a:ext cx="1005840" cy="365760"/>
+          </a:xfrm>
+          <a:prstGeom prst="rect">
+            <a:avLst/>
+          </a:prstGeom>
+          <a:noFill/>
+        </p:spPr>
+        <p:txBody>
+          <a:bodyPr wrap="none">
+            <a:spAutoFit/>
+          </a:bodyPr>
+          <a:lstStyle/>
+          <a:p>
+            <a:pPr algn="r"/>
+            <a:r>
+              <a:rPr sz="1100">
+                <a:solidFill>
+                  <a:srgbClr val="1F3864"/>
+                </a:solidFill>
+                <a:latin typeface="Calibri"/>
+              </a:rPr>
+              <a:t>8 / 8</a:t>
+            </a:r>
           </a:p>
         </p:txBody>
       </p:sp>

</xml_diff>

<commit_message>
Présentation : tirets longs remplacés sur la diapositive 6
</commit_message>
<xml_diff>
--- a/1_Spotify_Data_Governance/versions_docx_ppt/4_Presentation_Gouvernance_Spotify.pptx
+++ b/1_Spotify_Data_Governance/versions_docx_ppt/4_Presentation_Gouvernance_Spotify.pptx
@@ -4000,7 +4000,7 @@
                 <a:ea typeface="Calibri" pitchFamily="34" charset="-122"/>
                 <a:cs typeface="Calibri" pitchFamily="34" charset="-120"/>
               </a:rPr>
-              <a:t>Acheter — outils du marché</a:t>
+              <a:t>Acheter - outils du marché</a:t>
             </a:r>
             <a:endParaRPr lang="en-US" sz="1500" dirty="0"/>
           </a:p>
@@ -4043,7 +4043,7 @@
                 <a:ea typeface="Calibri" pitchFamily="34" charset="-122"/>
                 <a:cs typeface="Calibri" pitchFamily="34" charset="-120"/>
               </a:rPr>
-              <a:t>Collibra — catalogue de données</a:t>
+              <a:t>Collibra - catalogue de données</a:t>
             </a:r>
             <a:endParaRPr lang="en-US" sz="1300" dirty="0"/>
           </a:p>
@@ -4064,7 +4064,7 @@
                 <a:ea typeface="Calibri" pitchFamily="34" charset="-122"/>
                 <a:cs typeface="Calibri" pitchFamily="34" charset="-120"/>
               </a:rPr>
-              <a:t>Ataccama ONE — qualité des données</a:t>
+              <a:t>Ataccama ONE - qualité des données</a:t>
             </a:r>
             <a:endParaRPr lang="en-US" sz="1300" dirty="0"/>
           </a:p>
@@ -4085,7 +4085,7 @@
                 <a:ea typeface="Calibri" pitchFamily="34" charset="-122"/>
                 <a:cs typeface="Calibri" pitchFamily="34" charset="-120"/>
               </a:rPr>
-              <a:t>OneTrust — conformité</a:t>
+              <a:t>OneTrust - conformité</a:t>
             </a:r>
             <a:endParaRPr lang="en-US" sz="1300" dirty="0"/>
           </a:p>
@@ -4106,7 +4106,7 @@
                 <a:ea typeface="Calibri" pitchFamily="34" charset="-122"/>
                 <a:cs typeface="Calibri" pitchFamily="34" charset="-120"/>
               </a:rPr>
-              <a:t>Splunk — sécurité et supervision</a:t>
+              <a:t>Splunk - sécurité et supervision</a:t>
             </a:r>
             <a:endParaRPr lang="en-US" sz="1300" dirty="0"/>
           </a:p>
@@ -4171,7 +4171,7 @@
                 <a:ea typeface="Calibri" pitchFamily="34" charset="-122"/>
                 <a:cs typeface="Calibri" pitchFamily="34" charset="-120"/>
               </a:rPr>
-              <a:t>Construire — avantage propre</a:t>
+              <a:t>Construire - avantage propre</a:t>
             </a:r>
             <a:endParaRPr lang="en-US" sz="1500" dirty="0"/>
           </a:p>
@@ -4210,7 +4210,7 @@
                 <a:ea typeface="Calibri" pitchFamily="34" charset="-122"/>
                 <a:cs typeface="Calibri" pitchFamily="34" charset="-120"/>
               </a:rPr>
-              <a:t>Le cœur algorithmique — moteur de recommandation et surveillance des biais — est développé en interne, car c'est ce qui différencie Spotify.</a:t>
+              <a:t>Le cœur algorithmique, à savoir le moteur de recommandation et la surveillance des biais, est développé en interne, car c'est ce qui différencie Spotify.</a:t>
             </a:r>
             <a:endParaRPr lang="en-US" sz="1350" dirty="0"/>
           </a:p>

</xml_diff>

<commit_message>
Présentation Spotify : mise à jour du PowerPoint et du PDF
</commit_message>
<xml_diff>
--- a/1_Spotify_Data_Governance/versions_docx_ppt/4_Presentation_Gouvernance_Spotify.pptx
+++ b/1_Spotify_Data_Governance/versions_docx_ppt/4_Presentation_Gouvernance_Spotify.pptx
@@ -4,6 +4,9 @@
   <p:sldMasterIdLst>
     <p:sldMasterId id="2147483648" r:id="rId1"/>
   </p:sldMasterIdLst>
+  <p:notesMasterIdLst>
+    <p:notesMasterId r:id="rId10"/>
+  </p:notesMasterIdLst>
   <p:sldIdLst>
     <p:sldId id="256" r:id="rId2"/>
     <p:sldId id="257" r:id="rId3"/>
@@ -14,9 +17,6 @@
     <p:sldId id="262" r:id="rId8"/>
     <p:sldId id="263" r:id="rId9"/>
   </p:sldIdLst>
-  <p:notesMasterIdLst>
-    <p:notesMasterId r:id="rId10"/>
-  </p:notesMasterIdLst>
   <p:sldSz cx="12192000" cy="6858000"/>
   <p:notesSz cx="6858000" cy="12192000"/>
   <p:defaultTextStyle>
@@ -111,6 +111,11 @@
       </a:defRPr>
     </a:lvl9pPr>
   </p:defaultTextStyle>
+  <p:extLst>
+    <p:ext uri="{EFAFB233-063F-42B5-8137-9DF3F51BA10A}">
+      <p15:sldGuideLst xmlns:p15="http://schemas.microsoft.com/office/powerpoint/2012/main"/>
+    </p:ext>
+  </p:extLst>
 </p:presentation>
 </file>
 
@@ -136,234 +141,10 @@
           <a:chExt cx="0" cy="0"/>
         </a:xfrm>
       </p:grpSpPr>
-      <p:sp>
-        <p:nvSpPr>
-          <p:cNvPr id="2" name="Header Placeholder 1"/>
-          <p:cNvSpPr>
-            <a:spLocks noGrp="1"/>
-          </p:cNvSpPr>
-          <p:nvPr>
-            <p:ph type="hdr" sz="quarter"/>
-          </p:nvPr>
-        </p:nvSpPr>
-        <p:spPr>
-          <a:xfrm>
-            <a:off x="0" y="0"/>
-            <a:ext cx="2971800" cy="458788"/>
-          </a:xfrm>
-          <a:prstGeom prst="rect">
-            <a:avLst/>
-          </a:prstGeom>
-        </p:spPr>
-        <p:txBody>
-          <a:bodyPr vert="horz" lIns="91440" tIns="45720" rIns="91440" bIns="45720" rtlCol="0"/>
-          <a:lstStyle>
-            <a:lvl1pPr algn="l">
-              <a:defRPr sz="1200"/>
-            </a:lvl1pPr>
-          </a:lstStyle>
-          <a:p>
-            <a:endParaRPr lang="en-US"/>
-          </a:p>
-        </p:txBody>
-      </p:sp>
-      <p:sp>
-        <p:nvSpPr>
-          <p:cNvPr id="3" name="Date Placeholder 2"/>
-          <p:cNvSpPr>
-            <a:spLocks noGrp="1"/>
-          </p:cNvSpPr>
-          <p:nvPr>
-            <p:ph type="dt" idx="1"/>
-          </p:nvPr>
-        </p:nvSpPr>
-        <p:spPr>
-          <a:xfrm>
-            <a:off x="3884613" y="0"/>
-            <a:ext cx="2971800" cy="458788"/>
-          </a:xfrm>
-          <a:prstGeom prst="rect">
-            <a:avLst/>
-          </a:prstGeom>
-        </p:spPr>
-        <p:txBody>
-          <a:bodyPr vert="horz" lIns="91440" tIns="45720" rIns="91440" bIns="45720" rtlCol="0"/>
-          <a:lstStyle>
-            <a:lvl1pPr algn="r">
-              <a:defRPr sz="1200"/>
-            </a:lvl1pPr>
-          </a:lstStyle>
-          <a:p>
-            <a:fld id="{5282F153-3F37-0F45-9E97-73ACFA13230C}" type="datetimeFigureOut">
-              <a:rPr lang="en-US"/>
-              <a:t>7/23/19</a:t>
-            </a:fld>
-            <a:endParaRPr lang="en-US"/>
-          </a:p>
-        </p:txBody>
-      </p:sp>
-      <p:sp>
-        <p:nvSpPr>
-          <p:cNvPr id="4" name="Slide Image Placeholder 3"/>
-          <p:cNvSpPr>
-            <a:spLocks noGrp="1" noRot="1" noChangeAspect="1"/>
-          </p:cNvSpPr>
-          <p:nvPr>
-            <p:ph type="sldImg" idx="2"/>
-          </p:nvPr>
-        </p:nvSpPr>
-        <p:spPr>
-          <a:xfrm>
-            <a:off x="685800" y="1143000"/>
-            <a:ext cx="5486400" cy="3086100"/>
-          </a:xfrm>
-          <a:prstGeom prst="rect">
-            <a:avLst/>
-          </a:prstGeom>
-          <a:noFill/>
-          <a:ln w="12700">
-            <a:solidFill>
-              <a:prstClr val="black"/>
-            </a:solidFill>
-          </a:ln>
-        </p:spPr>
-        <p:txBody>
-          <a:bodyPr vert="horz" lIns="91440" tIns="45720" rIns="91440" bIns="45720" rtlCol="0" anchor="ctr"/>
-          <a:lstStyle/>
-          <a:p>
-            <a:endParaRPr lang="en-US"/>
-          </a:p>
-        </p:txBody>
-      </p:sp>
-      <p:sp>
-        <p:nvSpPr>
-          <p:cNvPr id="5" name="Notes Placeholder 4"/>
-          <p:cNvSpPr>
-            <a:spLocks noGrp="1"/>
-          </p:cNvSpPr>
-          <p:nvPr>
-            <p:ph type="body" sz="quarter" idx="3"/>
-          </p:nvPr>
-        </p:nvSpPr>
-        <p:spPr>
-          <a:xfrm>
-            <a:off x="685800" y="4400550"/>
-            <a:ext cx="5486400" cy="3600450"/>
-          </a:xfrm>
-          <a:prstGeom prst="rect">
-            <a:avLst/>
-          </a:prstGeom>
-        </p:spPr>
-        <p:txBody>
-          <a:bodyPr vert="horz" lIns="91440" tIns="45720" rIns="91440" bIns="45720" rtlCol="0"/>
-          <a:lstStyle/>
-          <a:p>
-            <a:pPr lvl="0"/>
-            <a:r>
-              <a:rPr lang="en-US"/>
-              <a:t>Click to edit Master text styles</a:t>
-            </a:r>
-          </a:p>
-          <a:p>
-            <a:pPr lvl="1"/>
-            <a:r>
-              <a:rPr lang="en-US"/>
-              <a:t>Second level</a:t>
-            </a:r>
-          </a:p>
-          <a:p>
-            <a:pPr lvl="2"/>
-            <a:r>
-              <a:rPr lang="en-US"/>
-              <a:t>Third level</a:t>
-            </a:r>
-          </a:p>
-          <a:p>
-            <a:pPr lvl="3"/>
-            <a:r>
-              <a:rPr lang="en-US"/>
-              <a:t>Fourth level</a:t>
-            </a:r>
-          </a:p>
-          <a:p>
-            <a:pPr lvl="4"/>
-            <a:r>
-              <a:rPr lang="en-US"/>
-              <a:t>Fifth level</a:t>
-            </a:r>
-          </a:p>
-        </p:txBody>
-      </p:sp>
-      <p:sp>
-        <p:nvSpPr>
-          <p:cNvPr id="6" name="Footer Placeholder 5"/>
-          <p:cNvSpPr>
-            <a:spLocks noGrp="1"/>
-          </p:cNvSpPr>
-          <p:nvPr>
-            <p:ph type="ftr" sz="quarter" idx="4"/>
-          </p:nvPr>
-        </p:nvSpPr>
-        <p:spPr>
-          <a:xfrm>
-            <a:off x="0" y="8685213"/>
-            <a:ext cx="2971800" cy="458787"/>
-          </a:xfrm>
-          <a:prstGeom prst="rect">
-            <a:avLst/>
-          </a:prstGeom>
-        </p:spPr>
-        <p:txBody>
-          <a:bodyPr vert="horz" lIns="91440" tIns="45720" rIns="91440" bIns="45720" rtlCol="0" anchor="b"/>
-          <a:lstStyle>
-            <a:lvl1pPr algn="l">
-              <a:defRPr sz="1200"/>
-            </a:lvl1pPr>
-          </a:lstStyle>
-          <a:p>
-            <a:endParaRPr lang="en-US"/>
-          </a:p>
-        </p:txBody>
-      </p:sp>
-      <p:sp>
-        <p:nvSpPr>
-          <p:cNvPr id="7" name="Slide Number Placeholder 6"/>
-          <p:cNvSpPr>
-            <a:spLocks noGrp="1"/>
-          </p:cNvSpPr>
-          <p:nvPr>
-            <p:ph type="sldNum" sz="quarter" idx="5"/>
-          </p:nvPr>
-        </p:nvSpPr>
-        <p:spPr>
-          <a:xfrm>
-            <a:off x="3884613" y="8685213"/>
-            <a:ext cx="2971800" cy="458787"/>
-          </a:xfrm>
-          <a:prstGeom prst="rect">
-            <a:avLst/>
-          </a:prstGeom>
-        </p:spPr>
-        <p:txBody>
-          <a:bodyPr vert="horz" lIns="91440" tIns="45720" rIns="91440" bIns="45720" rtlCol="0" anchor="b"/>
-          <a:lstStyle>
-            <a:lvl1pPr algn="r">
-              <a:defRPr sz="1200"/>
-            </a:lvl1pPr>
-          </a:lstStyle>
-          <a:p>
-            <a:fld id="{CE5E9CC1-C706-0F49-92D6-E571CC5EEA8F}" type="slidenum">
-              <a:rPr lang="en-US"/>
-              <a:t>‹#›</a:t>
-            </a:fld>
-            <a:endParaRPr lang="en-US"/>
-          </a:p>
-        </p:txBody>
-      </p:sp>
     </p:spTree>
     <p:extLst>
       <p:ext uri="{BB962C8B-B14F-4D97-AF65-F5344CB8AC3E}">
-        <p14:creationId xmlns:p14="http://schemas.microsoft.com/office/powerpoint/2010/main" val="1024086991"/>
+        <p14:creationId xmlns:p14="http://schemas.microsoft.com/office/powerpoint/2010/main" val="192403938"/>
       </p:ext>
     </p:extLst>
   </p:cSld>
@@ -507,10 +288,6 @@
           <a:bodyPr/>
           <a:lstStyle/>
           <a:p>
-            <a:r>
-              <a:rPr lang="en-US" dirty="0"/>
-              <a:t/>
-            </a:r>
             <a:endParaRPr lang="en-US" dirty="0"/>
           </a:p>
         </p:txBody>
@@ -595,10 +372,6 @@
           <a:bodyPr/>
           <a:lstStyle/>
           <a:p>
-            <a:r>
-              <a:rPr lang="en-US" dirty="0"/>
-              <a:t/>
-            </a:r>
             <a:endParaRPr lang="en-US" dirty="0"/>
           </a:p>
         </p:txBody>
@@ -683,10 +456,6 @@
           <a:bodyPr/>
           <a:lstStyle/>
           <a:p>
-            <a:r>
-              <a:rPr lang="en-US" dirty="0"/>
-              <a:t/>
-            </a:r>
             <a:endParaRPr lang="en-US" dirty="0"/>
           </a:p>
         </p:txBody>
@@ -771,10 +540,6 @@
           <a:bodyPr/>
           <a:lstStyle/>
           <a:p>
-            <a:r>
-              <a:rPr lang="en-US" dirty="0"/>
-              <a:t/>
-            </a:r>
             <a:endParaRPr lang="en-US" dirty="0"/>
           </a:p>
         </p:txBody>
@@ -859,10 +624,6 @@
           <a:bodyPr/>
           <a:lstStyle/>
           <a:p>
-            <a:r>
-              <a:rPr lang="en-US" dirty="0"/>
-              <a:t/>
-            </a:r>
             <a:endParaRPr lang="en-US" dirty="0"/>
           </a:p>
         </p:txBody>
@@ -947,10 +708,6 @@
           <a:bodyPr/>
           <a:lstStyle/>
           <a:p>
-            <a:r>
-              <a:rPr lang="en-US" dirty="0"/>
-              <a:t/>
-            </a:r>
             <a:endParaRPr lang="en-US" dirty="0"/>
           </a:p>
         </p:txBody>
@@ -1035,10 +792,6 @@
           <a:bodyPr/>
           <a:lstStyle/>
           <a:p>
-            <a:r>
-              <a:rPr lang="en-US" dirty="0"/>
-              <a:t/>
-            </a:r>
             <a:endParaRPr lang="en-US" dirty="0"/>
           </a:p>
         </p:txBody>
@@ -1123,10 +876,6 @@
           <a:bodyPr/>
           <a:lstStyle/>
           <a:p>
-            <a:r>
-              <a:rPr lang="en-US" dirty="0"/>
-              <a:t/>
-            </a:r>
             <a:endParaRPr lang="en-US" dirty="0"/>
           </a:p>
         </p:txBody>
@@ -1205,6 +954,7 @@
         <a:solidFill>
           <a:srgbClr val="FFFFFF"/>
         </a:solidFill>
+        <a:effectLst/>
       </p:bgPr>
     </p:bg>
     <p:spTree>
@@ -1232,6 +982,11 @@
 <file path=ppt/slideMasters/slideMaster1.xml><?xml version="1.0" encoding="utf-8"?>
 <p:sldMaster xmlns:a="http://schemas.openxmlformats.org/drawingml/2006/main" xmlns:r="http://schemas.openxmlformats.org/officeDocument/2006/relationships" xmlns:p="http://schemas.openxmlformats.org/presentationml/2006/main">
   <p:cSld>
+    <p:bg>
+      <p:bgRef idx="1001">
+        <a:schemeClr val="bg1"/>
+      </p:bgRef>
+    </p:bg>
     <p:spTree>
       <p:nvGrpSpPr>
         <p:cNvPr id="1" name=""/>
@@ -1513,7 +1268,7 @@
     <p:bg>
       <p:bgPr>
         <a:blipFill dpi="0" rotWithShape="1">
-          <a:blip r:embed="rId1">
+          <a:blip r:embed="rId3">
             <a:lum/>
           </a:blip>
           <a:srcRect/>
@@ -1619,11 +1374,11 @@
           <a:bodyPr wrap="square" lIns="0" tIns="0" rIns="0" bIns="0" rtlCol="0" anchor="ctr"/>
           <a:lstStyle/>
           <a:p>
-            <a:pPr indent="0" marL="0">
+            <a:pPr marL="0" indent="0">
               <a:buNone/>
             </a:pPr>
             <a:r>
-              <a:rPr lang="en-US" sz="1200" b="1" spc="200" kern="0" dirty="0">
+              <a:rPr lang="en-US" sz="1200" b="1" kern="0" spc="200" dirty="0">
                 <a:solidFill>
                   <a:srgbClr val="2E5496"/>
                 </a:solidFill>
@@ -1658,7 +1413,7 @@
           <a:bodyPr wrap="square" lIns="0" tIns="0" rIns="0" bIns="0" rtlCol="0" anchor="ctr"/>
           <a:lstStyle/>
           <a:p>
-            <a:pPr indent="0" marL="0">
+            <a:pPr marL="0" indent="0">
               <a:buNone/>
             </a:pPr>
             <a:r>
@@ -1699,7 +1454,10 @@
         </p:spPr>
         <p:txBody>
           <a:bodyPr/>
-          <a:p/>
+          <a:lstStyle/>
+          <a:p>
+            <a:endParaRPr/>
+          </a:p>
         </p:txBody>
       </p:sp>
       <p:sp>
@@ -1723,7 +1481,7 @@
           <a:bodyPr wrap="square" lIns="0" tIns="0" rIns="0" bIns="0" rtlCol="0" anchor="ctr"/>
           <a:lstStyle/>
           <a:p>
-            <a:pPr indent="0" marL="0">
+            <a:pPr marL="0" indent="0">
               <a:buNone/>
             </a:pPr>
             <a:r>
@@ -1762,7 +1520,7 @@
           <a:bodyPr wrap="square" lIns="0" tIns="0" rIns="0" bIns="0" rtlCol="0" anchor="t"/>
           <a:lstStyle/>
           <a:p>
-            <a:pPr indent="0" marL="0">
+            <a:pPr marL="0" indent="0">
               <a:buNone/>
             </a:pPr>
             <a:r>
@@ -1803,7 +1561,10 @@
         </p:spPr>
         <p:txBody>
           <a:bodyPr/>
-          <a:p/>
+          <a:lstStyle/>
+          <a:p>
+            <a:endParaRPr/>
+          </a:p>
         </p:txBody>
       </p:sp>
       <p:sp>
@@ -1827,7 +1588,7 @@
           <a:bodyPr wrap="square" lIns="0" tIns="0" rIns="0" bIns="0" rtlCol="0" anchor="ctr"/>
           <a:lstStyle/>
           <a:p>
-            <a:pPr indent="0" marL="0">
+            <a:pPr marL="0" indent="0">
               <a:buNone/>
             </a:pPr>
             <a:r>
@@ -1866,7 +1627,7 @@
           <a:bodyPr wrap="square" lIns="0" tIns="0" rIns="0" bIns="0" rtlCol="0" anchor="t"/>
           <a:lstStyle/>
           <a:p>
-            <a:pPr indent="0" marL="0">
+            <a:pPr marL="0" indent="0">
               <a:buNone/>
             </a:pPr>
             <a:r>
@@ -1907,7 +1668,10 @@
         </p:spPr>
         <p:txBody>
           <a:bodyPr/>
-          <a:p/>
+          <a:lstStyle/>
+          <a:p>
+            <a:endParaRPr/>
+          </a:p>
         </p:txBody>
       </p:sp>
       <p:sp>
@@ -1931,7 +1695,7 @@
           <a:bodyPr wrap="square" lIns="0" tIns="0" rIns="0" bIns="0" rtlCol="0" anchor="ctr"/>
           <a:lstStyle/>
           <a:p>
-            <a:pPr indent="0" marL="0">
+            <a:pPr marL="0" indent="0">
               <a:buNone/>
             </a:pPr>
             <a:r>
@@ -1970,7 +1734,7 @@
           <a:bodyPr wrap="square" lIns="0" tIns="0" rIns="0" bIns="0" rtlCol="0" anchor="t"/>
           <a:lstStyle/>
           <a:p>
-            <a:pPr indent="0" marL="0">
+            <a:pPr marL="0" indent="0">
               <a:buNone/>
             </a:pPr>
             <a:r>
@@ -2011,7 +1775,10 @@
         </p:spPr>
         <p:txBody>
           <a:bodyPr/>
-          <a:p/>
+          <a:lstStyle/>
+          <a:p>
+            <a:endParaRPr/>
+          </a:p>
         </p:txBody>
       </p:sp>
       <p:sp>
@@ -2035,7 +1802,7 @@
           <a:bodyPr wrap="square" lIns="0" tIns="0" rIns="0" bIns="0" rtlCol="0" anchor="ctr"/>
           <a:lstStyle/>
           <a:p>
-            <a:pPr algn="ctr" indent="0" marL="0">
+            <a:pPr marL="0" indent="0" algn="ctr">
               <a:buNone/>
             </a:pPr>
             <a:r>
@@ -2047,7 +1814,7 @@
                 <a:ea typeface="Calibri" pitchFamily="34" charset="-122"/>
                 <a:cs typeface="Calibri" pitchFamily="34" charset="-120"/>
               </a:rPr>
-              <a:t>2,8 / 5</a:t>
+              <a:t>2,8/5</a:t>
             </a:r>
             <a:endParaRPr lang="en-US" sz="6000" dirty="0"/>
           </a:p>
@@ -2074,7 +1841,7 @@
           <a:bodyPr wrap="square" lIns="0" tIns="0" rIns="0" bIns="0" rtlCol="0" anchor="ctr"/>
           <a:lstStyle/>
           <a:p>
-            <a:pPr indent="0" marL="0">
+            <a:pPr marL="0" indent="0">
               <a:buNone/>
             </a:pPr>
             <a:r>
@@ -2113,7 +1880,7 @@
           <a:bodyPr wrap="square" lIns="0" tIns="0" rIns="0" bIns="0" rtlCol="0" anchor="t"/>
           <a:lstStyle/>
           <a:p>
-            <a:pPr indent="0" marL="0">
+            <a:pPr marL="0" indent="0">
               <a:buNone/>
             </a:pPr>
             <a:r>
@@ -2212,11 +1979,11 @@
           <a:bodyPr wrap="square" lIns="0" tIns="0" rIns="0" bIns="0" rtlCol="0" anchor="ctr"/>
           <a:lstStyle/>
           <a:p>
-            <a:pPr indent="0" marL="0">
+            <a:pPr marL="0" indent="0">
               <a:buNone/>
             </a:pPr>
             <a:r>
-              <a:rPr lang="en-US" sz="1200" b="1" spc="200" kern="0" dirty="0">
+              <a:rPr lang="en-US" sz="1200" b="1" kern="0" spc="200" dirty="0">
                 <a:solidFill>
                   <a:srgbClr val="2E5496"/>
                 </a:solidFill>
@@ -2251,7 +2018,7 @@
           <a:bodyPr wrap="square" lIns="0" tIns="0" rIns="0" bIns="0" rtlCol="0" anchor="ctr"/>
           <a:lstStyle/>
           <a:p>
-            <a:pPr indent="0" marL="0">
+            <a:pPr marL="0" indent="0">
               <a:buNone/>
             </a:pPr>
             <a:r>
@@ -2292,7 +2059,10 @@
         </p:spPr>
         <p:txBody>
           <a:bodyPr/>
-          <a:p/>
+          <a:lstStyle/>
+          <a:p>
+            <a:endParaRPr/>
+          </a:p>
         </p:txBody>
       </p:sp>
       <p:sp>
@@ -2316,7 +2086,7 @@
           <a:bodyPr wrap="square" lIns="0" tIns="0" rIns="0" bIns="0" rtlCol="0" anchor="ctr"/>
           <a:lstStyle/>
           <a:p>
-            <a:pPr indent="0" marL="0">
+            <a:pPr marL="0" indent="0">
               <a:buNone/>
             </a:pPr>
             <a:r>
@@ -2463,7 +2233,10 @@
         </p:spPr>
         <p:txBody>
           <a:bodyPr/>
-          <a:p/>
+          <a:lstStyle/>
+          <a:p>
+            <a:endParaRPr/>
+          </a:p>
         </p:txBody>
       </p:sp>
       <p:sp>
@@ -2487,7 +2260,7 @@
           <a:bodyPr wrap="square" lIns="0" tIns="0" rIns="0" bIns="0" rtlCol="0" anchor="ctr"/>
           <a:lstStyle/>
           <a:p>
-            <a:pPr indent="0" marL="0">
+            <a:pPr marL="0" indent="0">
               <a:buNone/>
             </a:pPr>
             <a:r>
@@ -2692,11 +2465,11 @@
           <a:bodyPr wrap="square" lIns="0" tIns="0" rIns="0" bIns="0" rtlCol="0" anchor="ctr"/>
           <a:lstStyle/>
           <a:p>
-            <a:pPr indent="0" marL="0">
+            <a:pPr marL="0" indent="0">
               <a:buNone/>
             </a:pPr>
             <a:r>
-              <a:rPr lang="en-US" sz="1200" b="1" spc="200" kern="0" dirty="0">
+              <a:rPr lang="en-US" sz="1200" b="1" kern="0" spc="200" dirty="0">
                 <a:solidFill>
                   <a:srgbClr val="2E5496"/>
                 </a:solidFill>
@@ -2731,7 +2504,7 @@
           <a:bodyPr wrap="square" lIns="0" tIns="0" rIns="0" bIns="0" rtlCol="0" anchor="ctr"/>
           <a:lstStyle/>
           <a:p>
-            <a:pPr indent="0" marL="0">
+            <a:pPr marL="0" indent="0">
               <a:buNone/>
             </a:pPr>
             <a:r>
@@ -2772,7 +2545,10 @@
         </p:spPr>
         <p:txBody>
           <a:bodyPr/>
-          <a:p/>
+          <a:lstStyle/>
+          <a:p>
+            <a:endParaRPr/>
+          </a:p>
         </p:txBody>
       </p:sp>
       <p:sp>
@@ -2796,7 +2572,7 @@
           <a:bodyPr wrap="square" lIns="0" tIns="0" rIns="0" bIns="0" rtlCol="0" anchor="ctr"/>
           <a:lstStyle/>
           <a:p>
-            <a:pPr algn="ctr" indent="0" marL="0">
+            <a:pPr marL="0" indent="0" algn="ctr">
               <a:buNone/>
             </a:pPr>
             <a:r>
@@ -2837,7 +2613,10 @@
         </p:spPr>
         <p:txBody>
           <a:bodyPr/>
-          <a:p/>
+          <a:lstStyle/>
+          <a:p>
+            <a:endParaRPr/>
+          </a:p>
         </p:txBody>
       </p:sp>
       <p:sp>
@@ -2861,7 +2640,7 @@
           <a:bodyPr wrap="square" lIns="0" tIns="0" rIns="0" bIns="0" rtlCol="0" anchor="ctr"/>
           <a:lstStyle/>
           <a:p>
-            <a:pPr algn="ctr" indent="0" marL="0">
+            <a:pPr marL="0" indent="0" algn="ctr">
               <a:buNone/>
             </a:pPr>
             <a:r>
@@ -2902,7 +2681,10 @@
         </p:spPr>
         <p:txBody>
           <a:bodyPr/>
-          <a:p/>
+          <a:lstStyle/>
+          <a:p>
+            <a:endParaRPr/>
+          </a:p>
         </p:txBody>
       </p:sp>
       <p:sp>
@@ -2926,7 +2708,7 @@
           <a:bodyPr wrap="square" lIns="0" tIns="0" rIns="0" bIns="0" rtlCol="0" anchor="ctr"/>
           <a:lstStyle/>
           <a:p>
-            <a:pPr algn="ctr" indent="0" marL="0">
+            <a:pPr marL="0" indent="0" algn="ctr">
               <a:buNone/>
             </a:pPr>
             <a:r>
@@ -2967,7 +2749,10 @@
         </p:spPr>
         <p:txBody>
           <a:bodyPr/>
-          <a:p/>
+          <a:lstStyle/>
+          <a:p>
+            <a:endParaRPr/>
+          </a:p>
         </p:txBody>
       </p:sp>
       <p:sp>
@@ -2991,7 +2776,7 @@
           <a:bodyPr wrap="square" lIns="0" tIns="0" rIns="0" bIns="0" rtlCol="0" anchor="ctr"/>
           <a:lstStyle/>
           <a:p>
-            <a:pPr algn="ctr" indent="0" marL="0">
+            <a:pPr marL="0" indent="0" algn="ctr">
               <a:buNone/>
             </a:pPr>
             <a:r>
@@ -3032,7 +2817,10 @@
         </p:spPr>
         <p:txBody>
           <a:bodyPr/>
-          <a:p/>
+          <a:lstStyle/>
+          <a:p>
+            <a:endParaRPr/>
+          </a:p>
         </p:txBody>
       </p:sp>
       <p:sp>
@@ -3056,7 +2844,7 @@
           <a:bodyPr wrap="square" lIns="0" tIns="0" rIns="0" bIns="0" rtlCol="0" anchor="ctr"/>
           <a:lstStyle/>
           <a:p>
-            <a:pPr algn="ctr" indent="0" marL="0">
+            <a:pPr marL="0" indent="0" algn="ctr">
               <a:buNone/>
             </a:pPr>
             <a:r>
@@ -3097,7 +2885,10 @@
         </p:spPr>
         <p:txBody>
           <a:bodyPr/>
-          <a:p/>
+          <a:lstStyle/>
+          <a:p>
+            <a:endParaRPr/>
+          </a:p>
         </p:txBody>
       </p:sp>
       <p:sp>
@@ -3121,7 +2912,7 @@
           <a:bodyPr wrap="square" lIns="0" tIns="0" rIns="0" bIns="0" rtlCol="0" anchor="ctr"/>
           <a:lstStyle/>
           <a:p>
-            <a:pPr algn="ctr" indent="0" marL="0">
+            <a:pPr marL="0" indent="0" algn="ctr">
               <a:buNone/>
             </a:pPr>
             <a:r>
@@ -3162,7 +2953,10 @@
         </p:spPr>
         <p:txBody>
           <a:bodyPr/>
-          <a:p/>
+          <a:lstStyle/>
+          <a:p>
+            <a:endParaRPr/>
+          </a:p>
         </p:txBody>
       </p:sp>
       <p:sp>
@@ -3186,7 +2980,7 @@
           <a:bodyPr wrap="square" lIns="0" tIns="0" rIns="0" bIns="0" rtlCol="0" anchor="ctr"/>
           <a:lstStyle/>
           <a:p>
-            <a:pPr algn="ctr" indent="0" marL="0">
+            <a:pPr marL="0" indent="0" algn="ctr">
               <a:buNone/>
             </a:pPr>
             <a:r>
@@ -3227,7 +3021,10 @@
         </p:spPr>
         <p:txBody>
           <a:bodyPr/>
-          <a:p/>
+          <a:lstStyle/>
+          <a:p>
+            <a:endParaRPr/>
+          </a:p>
         </p:txBody>
       </p:sp>
       <p:sp>
@@ -3251,7 +3048,7 @@
           <a:bodyPr wrap="square" lIns="0" tIns="0" rIns="0" bIns="0" rtlCol="0" anchor="ctr"/>
           <a:lstStyle/>
           <a:p>
-            <a:pPr algn="ctr" indent="0" marL="0">
+            <a:pPr marL="0" indent="0" algn="ctr">
               <a:buNone/>
             </a:pPr>
             <a:r>
@@ -3292,7 +3089,10 @@
         </p:spPr>
         <p:txBody>
           <a:bodyPr/>
-          <a:p/>
+          <a:lstStyle/>
+          <a:p>
+            <a:endParaRPr/>
+          </a:p>
         </p:txBody>
       </p:sp>
       <p:sp>
@@ -3316,7 +3116,7 @@
           <a:bodyPr wrap="square" lIns="0" tIns="0" rIns="0" bIns="0" rtlCol="0" anchor="ctr"/>
           <a:lstStyle/>
           <a:p>
-            <a:pPr algn="ctr" indent="0" marL="0">
+            <a:pPr marL="0" indent="0" algn="ctr">
               <a:buNone/>
             </a:pPr>
             <a:r>
@@ -3415,11 +3215,11 @@
           <a:bodyPr wrap="square" lIns="0" tIns="0" rIns="0" bIns="0" rtlCol="0" anchor="ctr"/>
           <a:lstStyle/>
           <a:p>
-            <a:pPr indent="0" marL="0">
+            <a:pPr marL="0" indent="0">
               <a:buNone/>
             </a:pPr>
             <a:r>
-              <a:rPr lang="en-US" sz="1200" b="1" spc="200" kern="0" dirty="0">
+              <a:rPr lang="en-US" sz="1200" b="1" kern="0" spc="200" dirty="0">
                 <a:solidFill>
                   <a:srgbClr val="2E5496"/>
                 </a:solidFill>
@@ -3454,7 +3254,7 @@
           <a:bodyPr wrap="square" lIns="0" tIns="0" rIns="0" bIns="0" rtlCol="0" anchor="ctr"/>
           <a:lstStyle/>
           <a:p>
-            <a:pPr indent="0" marL="0">
+            <a:pPr marL="0" indent="0">
               <a:buNone/>
             </a:pPr>
             <a:r>
@@ -3474,14 +3274,14 @@
       </p:sp>
       <p:pic>
         <p:nvPicPr>
-          <p:cNvPr id="4" name="Image 0" descr="/home/claude/org_chart.png">    </p:cNvPr>
+          <p:cNvPr id="4" name="Image 0" descr="/home/claude/org_chart.png"/>
           <p:cNvPicPr>
             <a:picLocks noChangeAspect="1"/>
           </p:cNvPicPr>
           <p:nvPr/>
         </p:nvPicPr>
         <p:blipFill>
-          <a:blip r:embed="rId1"/>
+          <a:blip r:embed="rId3"/>
           <a:stretch>
             <a:fillRect/>
           </a:stretch>
@@ -3517,7 +3317,7 @@
           <a:bodyPr wrap="square" lIns="0" tIns="0" rIns="0" bIns="0" rtlCol="0" anchor="ctr"/>
           <a:lstStyle/>
           <a:p>
-            <a:pPr indent="0" marL="0">
+            <a:pPr marL="0" indent="0">
               <a:buNone/>
             </a:pPr>
             <a:r>
@@ -3556,7 +3356,7 @@
           <a:bodyPr wrap="square" lIns="0" tIns="0" rIns="0" bIns="0" rtlCol="0" anchor="t"/>
           <a:lstStyle/>
           <a:p>
-            <a:pPr indent="0" marL="0">
+            <a:pPr marL="0" indent="0">
               <a:spcAft>
                 <a:spcPts val="1000"/>
               </a:spcAft>
@@ -3573,13 +3373,38 @@
               </a:rPr>
               <a:t>CDO</a:t>
             </a:r>
-            <a:pPr indent="0" marL="0">
+            <a:r>
+              <a:rPr lang="en-US" sz="1250" dirty="0">
+                <a:solidFill>
+                  <a:srgbClr val="222222"/>
+                </a:solidFill>
+                <a:latin typeface="Calibri" pitchFamily="34" charset="0"/>
+                <a:ea typeface="Calibri" pitchFamily="34" charset="-122"/>
+                <a:cs typeface="Calibri" pitchFamily="34" charset="-120"/>
+              </a:rPr>
+              <a:t>  stratégie de gouvernance</a:t>
+            </a:r>
+            <a:endParaRPr lang="en-US" sz="1250" dirty="0"/>
+          </a:p>
+          <a:p>
+            <a:pPr marL="0" indent="0">
               <a:spcAft>
                 <a:spcPts val="1000"/>
               </a:spcAft>
               <a:buNone/>
             </a:pPr>
             <a:r>
+              <a:rPr lang="en-US" sz="1250" b="1" dirty="0">
+                <a:solidFill>
+                  <a:srgbClr val="1F3864"/>
+                </a:solidFill>
+                <a:latin typeface="Calibri" pitchFamily="34" charset="0"/>
+                <a:ea typeface="Calibri" pitchFamily="34" charset="-122"/>
+                <a:cs typeface="Calibri" pitchFamily="34" charset="-120"/>
+              </a:rPr>
+              <a:t>Comité de gouvernance</a:t>
+            </a:r>
+            <a:r>
               <a:rPr lang="en-US" sz="1250" dirty="0">
                 <a:solidFill>
                   <a:srgbClr val="222222"/>
@@ -3588,12 +3413,12 @@
                 <a:ea typeface="Calibri" pitchFamily="34" charset="-122"/>
                 <a:cs typeface="Calibri" pitchFamily="34" charset="-120"/>
               </a:rPr>
-              <a:t>  stratégie de gouvernance</a:t>
+              <a:t>  validation des politiques</a:t>
             </a:r>
             <a:endParaRPr lang="en-US" sz="1250" dirty="0"/>
           </a:p>
           <a:p>
-            <a:pPr indent="0" marL="0">
+            <a:pPr marL="0" indent="0">
               <a:spcAft>
                 <a:spcPts val="1000"/>
               </a:spcAft>
@@ -3608,15 +3433,40 @@
                 <a:ea typeface="Calibri" pitchFamily="34" charset="-122"/>
                 <a:cs typeface="Calibri" pitchFamily="34" charset="-120"/>
               </a:rPr>
-              <a:t>Comité de gouvernance</a:t>
-            </a:r>
-            <a:pPr indent="0" marL="0">
+              <a:t>DPO et juridique</a:t>
+            </a:r>
+            <a:r>
+              <a:rPr lang="en-US" sz="1250" dirty="0">
+                <a:solidFill>
+                  <a:srgbClr val="222222"/>
+                </a:solidFill>
+                <a:latin typeface="Calibri" pitchFamily="34" charset="0"/>
+                <a:ea typeface="Calibri" pitchFamily="34" charset="-122"/>
+                <a:cs typeface="Calibri" pitchFamily="34" charset="-120"/>
+              </a:rPr>
+              <a:t>  conformité et risques</a:t>
+            </a:r>
+            <a:endParaRPr lang="en-US" sz="1250" dirty="0"/>
+          </a:p>
+          <a:p>
+            <a:pPr marL="0" indent="0">
               <a:spcAft>
                 <a:spcPts val="1000"/>
               </a:spcAft>
               <a:buNone/>
             </a:pPr>
             <a:r>
+              <a:rPr lang="en-US" sz="1250" b="1" dirty="0">
+                <a:solidFill>
+                  <a:srgbClr val="1F3864"/>
+                </a:solidFill>
+                <a:latin typeface="Calibri" pitchFamily="34" charset="0"/>
+                <a:ea typeface="Calibri" pitchFamily="34" charset="-122"/>
+                <a:cs typeface="Calibri" pitchFamily="34" charset="-120"/>
+              </a:rPr>
+              <a:t>Data Stewards</a:t>
+            </a:r>
+            <a:r>
               <a:rPr lang="en-US" sz="1250" dirty="0">
                 <a:solidFill>
                   <a:srgbClr val="222222"/>
@@ -3625,12 +3475,12 @@
                 <a:ea typeface="Calibri" pitchFamily="34" charset="-122"/>
                 <a:cs typeface="Calibri" pitchFamily="34" charset="-120"/>
               </a:rPr>
-              <a:t>  validation des politiques</a:t>
+              <a:t>  qualité et accès par domaine</a:t>
             </a:r>
             <a:endParaRPr lang="en-US" sz="1250" dirty="0"/>
           </a:p>
           <a:p>
-            <a:pPr indent="0" marL="0">
+            <a:pPr marL="0" indent="0">
               <a:spcAft>
                 <a:spcPts val="1000"/>
               </a:spcAft>
@@ -3645,35 +3495,29 @@
                 <a:ea typeface="Calibri" pitchFamily="34" charset="-122"/>
                 <a:cs typeface="Calibri" pitchFamily="34" charset="-120"/>
               </a:rPr>
-              <a:t>DPO et juridique</a:t>
-            </a:r>
-            <a:pPr indent="0" marL="0">
+              <a:t>Data Steward IA</a:t>
+            </a:r>
+            <a:r>
+              <a:rPr lang="en-US" sz="1250" dirty="0">
+                <a:solidFill>
+                  <a:srgbClr val="222222"/>
+                </a:solidFill>
+                <a:latin typeface="Calibri" pitchFamily="34" charset="0"/>
+                <a:ea typeface="Calibri" pitchFamily="34" charset="-122"/>
+                <a:cs typeface="Calibri" pitchFamily="34" charset="-120"/>
+              </a:rPr>
+              <a:t>  biais et données d'entraînement</a:t>
+            </a:r>
+            <a:endParaRPr lang="en-US" sz="1250" dirty="0"/>
+          </a:p>
+          <a:p>
+            <a:pPr marL="0" indent="0">
               <a:spcAft>
                 <a:spcPts val="1000"/>
               </a:spcAft>
               <a:buNone/>
             </a:pPr>
             <a:r>
-              <a:rPr lang="en-US" sz="1250" dirty="0">
-                <a:solidFill>
-                  <a:srgbClr val="222222"/>
-                </a:solidFill>
-                <a:latin typeface="Calibri" pitchFamily="34" charset="0"/>
-                <a:ea typeface="Calibri" pitchFamily="34" charset="-122"/>
-                <a:cs typeface="Calibri" pitchFamily="34" charset="-120"/>
-              </a:rPr>
-              <a:t>  conformité et risques</a:t>
-            </a:r>
-            <a:endParaRPr lang="en-US" sz="1250" dirty="0"/>
-          </a:p>
-          <a:p>
-            <a:pPr indent="0" marL="0">
-              <a:spcAft>
-                <a:spcPts val="1000"/>
-              </a:spcAft>
-              <a:buNone/>
-            </a:pPr>
-            <a:r>
               <a:rPr lang="en-US" sz="1250" b="1" dirty="0">
                 <a:solidFill>
                   <a:srgbClr val="1F3864"/>
@@ -3682,88 +3526,8 @@
                 <a:ea typeface="Calibri" pitchFamily="34" charset="-122"/>
                 <a:cs typeface="Calibri" pitchFamily="34" charset="-120"/>
               </a:rPr>
-              <a:t>Data Stewards</a:t>
-            </a:r>
-            <a:pPr indent="0" marL="0">
-              <a:spcAft>
-                <a:spcPts val="1000"/>
-              </a:spcAft>
-              <a:buNone/>
-            </a:pPr>
-            <a:r>
-              <a:rPr lang="en-US" sz="1250" dirty="0">
-                <a:solidFill>
-                  <a:srgbClr val="222222"/>
-                </a:solidFill>
-                <a:latin typeface="Calibri" pitchFamily="34" charset="0"/>
-                <a:ea typeface="Calibri" pitchFamily="34" charset="-122"/>
-                <a:cs typeface="Calibri" pitchFamily="34" charset="-120"/>
-              </a:rPr>
-              <a:t>  qualité et accès par domaine</a:t>
-            </a:r>
-            <a:endParaRPr lang="en-US" sz="1250" dirty="0"/>
-          </a:p>
-          <a:p>
-            <a:pPr indent="0" marL="0">
-              <a:spcAft>
-                <a:spcPts val="1000"/>
-              </a:spcAft>
-              <a:buNone/>
-            </a:pPr>
-            <a:r>
-              <a:rPr lang="en-US" sz="1250" b="1" dirty="0">
-                <a:solidFill>
-                  <a:srgbClr val="1F3864"/>
-                </a:solidFill>
-                <a:latin typeface="Calibri" pitchFamily="34" charset="0"/>
-                <a:ea typeface="Calibri" pitchFamily="34" charset="-122"/>
-                <a:cs typeface="Calibri" pitchFamily="34" charset="-120"/>
-              </a:rPr>
-              <a:t>Data Steward IA</a:t>
-            </a:r>
-            <a:pPr indent="0" marL="0">
-              <a:spcAft>
-                <a:spcPts val="1000"/>
-              </a:spcAft>
-              <a:buNone/>
-            </a:pPr>
-            <a:r>
-              <a:rPr lang="en-US" sz="1250" dirty="0">
-                <a:solidFill>
-                  <a:srgbClr val="222222"/>
-                </a:solidFill>
-                <a:latin typeface="Calibri" pitchFamily="34" charset="0"/>
-                <a:ea typeface="Calibri" pitchFamily="34" charset="-122"/>
-                <a:cs typeface="Calibri" pitchFamily="34" charset="-120"/>
-              </a:rPr>
-              <a:t>  biais et données d'entraînement</a:t>
-            </a:r>
-            <a:endParaRPr lang="en-US" sz="1250" dirty="0"/>
-          </a:p>
-          <a:p>
-            <a:pPr indent="0" marL="0">
-              <a:spcAft>
-                <a:spcPts val="1000"/>
-              </a:spcAft>
-              <a:buNone/>
-            </a:pPr>
-            <a:r>
-              <a:rPr lang="en-US" sz="1250" b="1" dirty="0">
-                <a:solidFill>
-                  <a:srgbClr val="1F3864"/>
-                </a:solidFill>
-                <a:latin typeface="Calibri" pitchFamily="34" charset="0"/>
-                <a:ea typeface="Calibri" pitchFamily="34" charset="-122"/>
-                <a:cs typeface="Calibri" pitchFamily="34" charset="-120"/>
-              </a:rPr>
               <a:t>Directions métier</a:t>
             </a:r>
-            <a:pPr indent="0" marL="0">
-              <a:spcAft>
-                <a:spcPts val="1000"/>
-              </a:spcAft>
-              <a:buNone/>
-            </a:pPr>
             <a:r>
               <a:rPr lang="en-US" sz="1250" dirty="0">
                 <a:solidFill>
@@ -3860,11 +3624,11 @@
           <a:bodyPr wrap="square" lIns="0" tIns="0" rIns="0" bIns="0" rtlCol="0" anchor="ctr"/>
           <a:lstStyle/>
           <a:p>
-            <a:pPr indent="0" marL="0">
+            <a:pPr marL="0" indent="0">
               <a:buNone/>
             </a:pPr>
             <a:r>
-              <a:rPr lang="en-US" sz="1200" b="1" spc="200" kern="0" dirty="0">
+              <a:rPr lang="en-US" sz="1200" b="1" kern="0" spc="200" dirty="0">
                 <a:solidFill>
                   <a:srgbClr val="2E5496"/>
                 </a:solidFill>
@@ -3899,7 +3663,7 @@
           <a:bodyPr wrap="square" lIns="0" tIns="0" rIns="0" bIns="0" rtlCol="0" anchor="ctr"/>
           <a:lstStyle/>
           <a:p>
-            <a:pPr indent="0" marL="0">
+            <a:pPr marL="0" indent="0">
               <a:buNone/>
             </a:pPr>
             <a:r>
@@ -3919,14 +3683,14 @@
       </p:sp>
       <p:pic>
         <p:nvPicPr>
-          <p:cNvPr id="4" name="Image 0" descr="/home/claude/trajectory.png">    </p:cNvPr>
+          <p:cNvPr id="4" name="Image 0" descr="/home/claude/trajectory.png"/>
           <p:cNvPicPr>
             <a:picLocks noChangeAspect="1"/>
           </p:cNvPicPr>
           <p:nvPr/>
         </p:nvPicPr>
         <p:blipFill>
-          <a:blip r:embed="rId1"/>
+          <a:blip r:embed="rId3"/>
           <a:stretch>
             <a:fillRect/>
           </a:stretch>
@@ -3964,7 +3728,10 @@
         </p:spPr>
         <p:txBody>
           <a:bodyPr/>
-          <a:p/>
+          <a:lstStyle/>
+          <a:p>
+            <a:endParaRPr/>
+          </a:p>
         </p:txBody>
       </p:sp>
       <p:sp>
@@ -3988,7 +3755,7 @@
           <a:bodyPr wrap="square" lIns="0" tIns="0" rIns="0" bIns="0" rtlCol="0" anchor="ctr"/>
           <a:lstStyle/>
           <a:p>
-            <a:pPr indent="0" marL="0">
+            <a:pPr marL="0" indent="0">
               <a:buNone/>
             </a:pPr>
             <a:r>
@@ -4135,7 +3902,10 @@
         </p:spPr>
         <p:txBody>
           <a:bodyPr/>
-          <a:p/>
+          <a:lstStyle/>
+          <a:p>
+            <a:endParaRPr/>
+          </a:p>
         </p:txBody>
       </p:sp>
       <p:sp>
@@ -4159,7 +3929,7 @@
           <a:bodyPr wrap="square" lIns="0" tIns="0" rIns="0" bIns="0" rtlCol="0" anchor="ctr"/>
           <a:lstStyle/>
           <a:p>
-            <a:pPr indent="0" marL="0">
+            <a:pPr marL="0" indent="0">
               <a:buNone/>
             </a:pPr>
             <a:r>
@@ -4198,7 +3968,7 @@
           <a:bodyPr wrap="square" lIns="0" tIns="0" rIns="0" bIns="0" rtlCol="0" anchor="t"/>
           <a:lstStyle/>
           <a:p>
-            <a:pPr indent="0" marL="0">
+            <a:pPr marL="0" indent="0">
               <a:buNone/>
             </a:pPr>
             <a:r>
@@ -4297,11 +4067,11 @@
           <a:bodyPr wrap="square" lIns="0" tIns="0" rIns="0" bIns="0" rtlCol="0" anchor="ctr"/>
           <a:lstStyle/>
           <a:p>
-            <a:pPr indent="0" marL="0">
+            <a:pPr marL="0" indent="0">
               <a:buNone/>
             </a:pPr>
             <a:r>
-              <a:rPr lang="en-US" sz="1200" b="1" spc="200" kern="0" dirty="0">
+              <a:rPr lang="en-US" sz="1200" b="1" kern="0" spc="200" dirty="0">
                 <a:solidFill>
                   <a:srgbClr val="2E5496"/>
                 </a:solidFill>
@@ -4336,7 +4106,7 @@
           <a:bodyPr wrap="square" lIns="0" tIns="0" rIns="0" bIns="0" rtlCol="0" anchor="ctr"/>
           <a:lstStyle/>
           <a:p>
-            <a:pPr indent="0" marL="0">
+            <a:pPr marL="0" indent="0">
               <a:buNone/>
             </a:pPr>
             <a:r>
@@ -4377,7 +4147,10 @@
         </p:spPr>
         <p:txBody>
           <a:bodyPr/>
-          <a:p/>
+          <a:lstStyle/>
+          <a:p>
+            <a:endParaRPr/>
+          </a:p>
         </p:txBody>
       </p:sp>
       <p:sp>
@@ -4401,7 +4174,7 @@
           <a:bodyPr wrap="square" lIns="0" tIns="0" rIns="0" bIns="0" rtlCol="0" anchor="ctr"/>
           <a:lstStyle/>
           <a:p>
-            <a:pPr indent="0" marL="0">
+            <a:pPr marL="0" indent="0">
               <a:buNone/>
             </a:pPr>
             <a:r>
@@ -4548,7 +4321,10 @@
         </p:spPr>
         <p:txBody>
           <a:bodyPr/>
-          <a:p/>
+          <a:lstStyle/>
+          <a:p>
+            <a:endParaRPr/>
+          </a:p>
         </p:txBody>
       </p:sp>
       <p:sp>
@@ -4572,7 +4348,7 @@
           <a:bodyPr wrap="square" lIns="0" tIns="0" rIns="0" bIns="0" rtlCol="0" anchor="ctr"/>
           <a:lstStyle/>
           <a:p>
-            <a:pPr indent="0" marL="0">
+            <a:pPr marL="0" indent="0">
               <a:buNone/>
             </a:pPr>
             <a:r>
@@ -4798,11 +4574,11 @@
           <a:bodyPr wrap="square" lIns="0" tIns="0" rIns="0" bIns="0" rtlCol="0" anchor="ctr"/>
           <a:lstStyle/>
           <a:p>
-            <a:pPr indent="0" marL="0">
+            <a:pPr marL="0" indent="0">
               <a:buNone/>
             </a:pPr>
             <a:r>
-              <a:rPr lang="en-US" sz="1200" b="1" spc="200" kern="0" dirty="0">
+              <a:rPr lang="en-US" sz="1200" b="1" kern="0" spc="200" dirty="0">
                 <a:solidFill>
                   <a:srgbClr val="2E5496"/>
                 </a:solidFill>
@@ -4837,7 +4613,7 @@
           <a:bodyPr wrap="square" lIns="0" tIns="0" rIns="0" bIns="0" rtlCol="0" anchor="ctr"/>
           <a:lstStyle/>
           <a:p>
-            <a:pPr indent="0" marL="0">
+            <a:pPr marL="0" indent="0">
               <a:buNone/>
             </a:pPr>
             <a:r>
@@ -4878,7 +4654,10 @@
         </p:spPr>
         <p:txBody>
           <a:bodyPr/>
-          <a:p/>
+          <a:lstStyle/>
+          <a:p>
+            <a:endParaRPr/>
+          </a:p>
         </p:txBody>
       </p:sp>
       <p:sp>
@@ -4902,7 +4681,7 @@
           <a:bodyPr wrap="square" lIns="0" tIns="0" rIns="0" bIns="0" rtlCol="0" anchor="ctr"/>
           <a:lstStyle/>
           <a:p>
-            <a:pPr indent="0" marL="0">
+            <a:pPr marL="0" indent="0">
               <a:buNone/>
             </a:pPr>
             <a:r>
@@ -5049,7 +4828,10 @@
         </p:spPr>
         <p:txBody>
           <a:bodyPr/>
-          <a:p/>
+          <a:lstStyle/>
+          <a:p>
+            <a:endParaRPr/>
+          </a:p>
         </p:txBody>
       </p:sp>
       <p:sp>
@@ -5073,7 +4855,7 @@
           <a:bodyPr wrap="square" lIns="0" tIns="0" rIns="0" bIns="0" rtlCol="0" anchor="ctr"/>
           <a:lstStyle/>
           <a:p>
-            <a:pPr indent="0" marL="0">
+            <a:pPr marL="0" indent="0">
               <a:buNone/>
             </a:pPr>
             <a:r>
@@ -5512,4 +5294,319 @@
     </a:ext>
   </a:extLst>
 </a:theme>
+</file>
+
+<file path=ppt/theme/theme2.xml><?xml version="1.0" encoding="utf-8"?>
+<a:theme xmlns:a="http://schemas.openxmlformats.org/drawingml/2006/main" name="Thème Office">
+  <a:themeElements>
+    <a:clrScheme name="Office">
+      <a:dk1>
+        <a:sysClr val="windowText" lastClr="000000"/>
+      </a:dk1>
+      <a:lt1>
+        <a:sysClr val="window" lastClr="FFFFFF"/>
+      </a:lt1>
+      <a:dk2>
+        <a:srgbClr val="0E2841"/>
+      </a:dk2>
+      <a:lt2>
+        <a:srgbClr val="E8E8E8"/>
+      </a:lt2>
+      <a:accent1>
+        <a:srgbClr val="156082"/>
+      </a:accent1>
+      <a:accent2>
+        <a:srgbClr val="E97132"/>
+      </a:accent2>
+      <a:accent3>
+        <a:srgbClr val="196B24"/>
+      </a:accent3>
+      <a:accent4>
+        <a:srgbClr val="0F9ED5"/>
+      </a:accent4>
+      <a:accent5>
+        <a:srgbClr val="A02B93"/>
+      </a:accent5>
+      <a:accent6>
+        <a:srgbClr val="4EA72E"/>
+      </a:accent6>
+      <a:hlink>
+        <a:srgbClr val="467886"/>
+      </a:hlink>
+      <a:folHlink>
+        <a:srgbClr val="96607D"/>
+      </a:folHlink>
+    </a:clrScheme>
+    <a:fontScheme name="Office">
+      <a:majorFont>
+        <a:latin typeface="Aptos Display" panose="02110004020202020204"/>
+        <a:ea typeface=""/>
+        <a:cs typeface=""/>
+        <a:font script="Jpan" typeface="游ゴシック Light"/>
+        <a:font script="Hang" typeface="맑은 고딕"/>
+        <a:font script="Hans" typeface="等线 Light"/>
+        <a:font script="Hant" typeface="新細明體"/>
+        <a:font script="Arab" typeface="Times New Roman"/>
+        <a:font script="Hebr" typeface="Times New Roman"/>
+        <a:font script="Thai" typeface="Angsana New"/>
+        <a:font script="Ethi" typeface="Nyala"/>
+        <a:font script="Beng" typeface="Vrinda"/>
+        <a:font script="Gujr" typeface="Shruti"/>
+        <a:font script="Khmr" typeface="MoolBoran"/>
+        <a:font script="Knda" typeface="Tunga"/>
+        <a:font script="Guru" typeface="Raavi"/>
+        <a:font script="Cans" typeface="Euphemia"/>
+        <a:font script="Cher" typeface="Plantagenet Cherokee"/>
+        <a:font script="Yiii" typeface="Microsoft Yi Baiti"/>
+        <a:font script="Tibt" typeface="Microsoft Himalaya"/>
+        <a:font script="Thaa" typeface="MV Boli"/>
+        <a:font script="Deva" typeface="Mangal"/>
+        <a:font script="Telu" typeface="Gautami"/>
+        <a:font script="Taml" typeface="Latha"/>
+        <a:font script="Syrc" typeface="Estrangelo Edessa"/>
+        <a:font script="Orya" typeface="Kalinga"/>
+        <a:font script="Mlym" typeface="Kartika"/>
+        <a:font script="Laoo" typeface="DokChampa"/>
+        <a:font script="Sinh" typeface="Iskoola Pota"/>
+        <a:font script="Mong" typeface="Mongolian Baiti"/>
+        <a:font script="Viet" typeface="Times New Roman"/>
+        <a:font script="Uigh" typeface="Microsoft Uighur"/>
+        <a:font script="Geor" typeface="Sylfaen"/>
+        <a:font script="Armn" typeface="Arial"/>
+        <a:font script="Bugi" typeface="Leelawadee UI"/>
+        <a:font script="Bopo" typeface="Microsoft JhengHei"/>
+        <a:font script="Java" typeface="Javanese Text"/>
+        <a:font script="Lisu" typeface="Segoe UI"/>
+        <a:font script="Mymr" typeface="Myanmar Text"/>
+        <a:font script="Nkoo" typeface="Ebrima"/>
+        <a:font script="Olck" typeface="Nirmala UI"/>
+        <a:font script="Osma" typeface="Ebrima"/>
+        <a:font script="Phag" typeface="Phagspa"/>
+        <a:font script="Syrn" typeface="Estrangelo Edessa"/>
+        <a:font script="Syrj" typeface="Estrangelo Edessa"/>
+        <a:font script="Syre" typeface="Estrangelo Edessa"/>
+        <a:font script="Sora" typeface="Nirmala UI"/>
+        <a:font script="Tale" typeface="Microsoft Tai Le"/>
+        <a:font script="Talu" typeface="Microsoft New Tai Lue"/>
+        <a:font script="Tfng" typeface="Ebrima"/>
+      </a:majorFont>
+      <a:minorFont>
+        <a:latin typeface="Aptos" panose="02110004020202020204"/>
+        <a:ea typeface=""/>
+        <a:cs typeface=""/>
+        <a:font script="Jpan" typeface="游ゴシック"/>
+        <a:font script="Hang" typeface="맑은 고딕"/>
+        <a:font script="Hans" typeface="等线"/>
+        <a:font script="Hant" typeface="新細明體"/>
+        <a:font script="Arab" typeface="Arial"/>
+        <a:font script="Hebr" typeface="Arial"/>
+        <a:font script="Thai" typeface="Cordia New"/>
+        <a:font script="Ethi" typeface="Nyala"/>
+        <a:font script="Beng" typeface="Vrinda"/>
+        <a:font script="Gujr" typeface="Shruti"/>
+        <a:font script="Khmr" typeface="DaunPenh"/>
+        <a:font script="Knda" typeface="Tunga"/>
+        <a:font script="Guru" typeface="Raavi"/>
+        <a:font script="Cans" typeface="Euphemia"/>
+        <a:font script="Cher" typeface="Plantagenet Cherokee"/>
+        <a:font script="Yiii" typeface="Microsoft Yi Baiti"/>
+        <a:font script="Tibt" typeface="Microsoft Himalaya"/>
+        <a:font script="Thaa" typeface="MV Boli"/>
+        <a:font script="Deva" typeface="Mangal"/>
+        <a:font script="Telu" typeface="Gautami"/>
+        <a:font script="Taml" typeface="Latha"/>
+        <a:font script="Syrc" typeface="Estrangelo Edessa"/>
+        <a:font script="Orya" typeface="Kalinga"/>
+        <a:font script="Mlym" typeface="Kartika"/>
+        <a:font script="Laoo" typeface="DokChampa"/>
+        <a:font script="Sinh" typeface="Iskoola Pota"/>
+        <a:font script="Mong" typeface="Mongolian Baiti"/>
+        <a:font script="Viet" typeface="Arial"/>
+        <a:font script="Uigh" typeface="Microsoft Uighur"/>
+        <a:font script="Geor" typeface="Sylfaen"/>
+        <a:font script="Armn" typeface="Arial"/>
+        <a:font script="Bugi" typeface="Leelawadee UI"/>
+        <a:font script="Bopo" typeface="Microsoft JhengHei"/>
+        <a:font script="Java" typeface="Javanese Text"/>
+        <a:font script="Lisu" typeface="Segoe UI"/>
+        <a:font script="Mymr" typeface="Myanmar Text"/>
+        <a:font script="Nkoo" typeface="Ebrima"/>
+        <a:font script="Olck" typeface="Nirmala UI"/>
+        <a:font script="Osma" typeface="Ebrima"/>
+        <a:font script="Phag" typeface="Phagspa"/>
+        <a:font script="Syrn" typeface="Estrangelo Edessa"/>
+        <a:font script="Syrj" typeface="Estrangelo Edessa"/>
+        <a:font script="Syre" typeface="Estrangelo Edessa"/>
+        <a:font script="Sora" typeface="Nirmala UI"/>
+        <a:font script="Tale" typeface="Microsoft Tai Le"/>
+        <a:font script="Talu" typeface="Microsoft New Tai Lue"/>
+        <a:font script="Tfng" typeface="Ebrima"/>
+      </a:minorFont>
+    </a:fontScheme>
+    <a:fmtScheme name="Office">
+      <a:fillStyleLst>
+        <a:solidFill>
+          <a:schemeClr val="phClr"/>
+        </a:solidFill>
+        <a:gradFill rotWithShape="1">
+          <a:gsLst>
+            <a:gs pos="0">
+              <a:schemeClr val="phClr">
+                <a:lumMod val="110000"/>
+                <a:satMod val="105000"/>
+                <a:tint val="67000"/>
+              </a:schemeClr>
+            </a:gs>
+            <a:gs pos="50000">
+              <a:schemeClr val="phClr">
+                <a:lumMod val="105000"/>
+                <a:satMod val="103000"/>
+                <a:tint val="73000"/>
+              </a:schemeClr>
+            </a:gs>
+            <a:gs pos="100000">
+              <a:schemeClr val="phClr">
+                <a:lumMod val="105000"/>
+                <a:satMod val="109000"/>
+                <a:tint val="81000"/>
+              </a:schemeClr>
+            </a:gs>
+          </a:gsLst>
+          <a:lin ang="5400000" scaled="0"/>
+        </a:gradFill>
+        <a:gradFill rotWithShape="1">
+          <a:gsLst>
+            <a:gs pos="0">
+              <a:schemeClr val="phClr">
+                <a:satMod val="103000"/>
+                <a:lumMod val="102000"/>
+                <a:tint val="94000"/>
+              </a:schemeClr>
+            </a:gs>
+            <a:gs pos="50000">
+              <a:schemeClr val="phClr">
+                <a:satMod val="110000"/>
+                <a:lumMod val="100000"/>
+                <a:shade val="100000"/>
+              </a:schemeClr>
+            </a:gs>
+            <a:gs pos="100000">
+              <a:schemeClr val="phClr">
+                <a:lumMod val="99000"/>
+                <a:satMod val="120000"/>
+                <a:shade val="78000"/>
+              </a:schemeClr>
+            </a:gs>
+          </a:gsLst>
+          <a:lin ang="5400000" scaled="0"/>
+        </a:gradFill>
+      </a:fillStyleLst>
+      <a:lnStyleLst>
+        <a:ln w="12700" cap="flat" cmpd="sng" algn="ctr">
+          <a:solidFill>
+            <a:schemeClr val="phClr"/>
+          </a:solidFill>
+          <a:prstDash val="solid"/>
+          <a:miter lim="800000"/>
+        </a:ln>
+        <a:ln w="19050" cap="flat" cmpd="sng" algn="ctr">
+          <a:solidFill>
+            <a:schemeClr val="phClr"/>
+          </a:solidFill>
+          <a:prstDash val="solid"/>
+          <a:miter lim="800000"/>
+        </a:ln>
+        <a:ln w="25400" cap="flat" cmpd="sng" algn="ctr">
+          <a:solidFill>
+            <a:schemeClr val="phClr"/>
+          </a:solidFill>
+          <a:prstDash val="solid"/>
+          <a:miter lim="800000"/>
+        </a:ln>
+      </a:lnStyleLst>
+      <a:effectStyleLst>
+        <a:effectStyle>
+          <a:effectLst/>
+        </a:effectStyle>
+        <a:effectStyle>
+          <a:effectLst/>
+        </a:effectStyle>
+        <a:effectStyle>
+          <a:effectLst>
+            <a:outerShdw blurRad="57150" dist="19050" dir="5400000" algn="ctr" rotWithShape="0">
+              <a:srgbClr val="000000">
+                <a:alpha val="63000"/>
+              </a:srgbClr>
+            </a:outerShdw>
+          </a:effectLst>
+        </a:effectStyle>
+      </a:effectStyleLst>
+      <a:bgFillStyleLst>
+        <a:solidFill>
+          <a:schemeClr val="phClr"/>
+        </a:solidFill>
+        <a:solidFill>
+          <a:schemeClr val="phClr">
+            <a:tint val="95000"/>
+            <a:satMod val="170000"/>
+          </a:schemeClr>
+        </a:solidFill>
+        <a:gradFill rotWithShape="1">
+          <a:gsLst>
+            <a:gs pos="0">
+              <a:schemeClr val="phClr">
+                <a:tint val="93000"/>
+                <a:satMod val="150000"/>
+                <a:shade val="98000"/>
+                <a:lumMod val="102000"/>
+              </a:schemeClr>
+            </a:gs>
+            <a:gs pos="50000">
+              <a:schemeClr val="phClr">
+                <a:tint val="98000"/>
+                <a:satMod val="130000"/>
+                <a:shade val="90000"/>
+                <a:lumMod val="103000"/>
+              </a:schemeClr>
+            </a:gs>
+            <a:gs pos="100000">
+              <a:schemeClr val="phClr">
+                <a:shade val="63000"/>
+                <a:satMod val="120000"/>
+              </a:schemeClr>
+            </a:gs>
+          </a:gsLst>
+          <a:lin ang="5400000" scaled="0"/>
+        </a:gradFill>
+      </a:bgFillStyleLst>
+    </a:fmtScheme>
+  </a:themeElements>
+  <a:objectDefaults>
+    <a:lnDef>
+      <a:spPr/>
+      <a:bodyPr/>
+      <a:lstStyle/>
+      <a:style>
+        <a:lnRef idx="2">
+          <a:schemeClr val="accent1"/>
+        </a:lnRef>
+        <a:fillRef idx="0">
+          <a:schemeClr val="accent1"/>
+        </a:fillRef>
+        <a:effectRef idx="1">
+          <a:schemeClr val="accent1"/>
+        </a:effectRef>
+        <a:fontRef idx="minor">
+          <a:schemeClr val="tx1"/>
+        </a:fontRef>
+      </a:style>
+    </a:lnDef>
+  </a:objectDefaults>
+  <a:extraClrSchemeLst/>
+  <a:extLst>
+    <a:ext uri="{05A4C25C-085E-4340-85A3-A5531E510DB2}">
+      <thm15:themeFamily xmlns:thm15="http://schemas.microsoft.com/office/thememl/2012/main" name="Office Theme" id="{2E142A2C-CD16-42D6-873A-C26D2A0506FA}" vid="{1BDDFF52-6CD6-40A5-AB3C-68EB2F1E4D0A}"/>
+    </a:ext>
+  </a:extLst>
+</a:theme>
 </file>
</xml_diff>